<commit_message>
data: rebuild analysis on Stack Overflow Developer Survey 2025 (49,191 respondents)
- analysis/recompute_from_survey.py: recompute tables from latest survey, same logic
- analysis/market_data.json: computed signals (language/database/salary/role/country)
- market_insight_data.py now loads live numbers; regenerate dashboard/pptx/sql/pbip/CSVs
- IDE kept from last survey that asked it (2025 dropped the IDE question)
</commit_message>
<xml_diff>
--- a/docs/presentation.pptx
+++ b/docs/presentation.pptx
@@ -170,28 +170,28 @@
               <c:strCache>
                 <c:ptCount val="8"/>
                 <c:pt idx="0">
-                  <c:v>Java</c:v>
+                  <c:v>Go</c:v>
                 </c:pt>
                 <c:pt idx="1">
-                  <c:v>Bash/Shell/PowerShell</c:v>
+                  <c:v>Bash/Shell (all shells)</c:v>
                 </c:pt>
                 <c:pt idx="2">
-                  <c:v>C#</c:v>
+                  <c:v>Rust</c:v>
                 </c:pt>
                 <c:pt idx="3">
                   <c:v>TypeScript</c:v>
                 </c:pt>
                 <c:pt idx="4">
+                  <c:v>JavaScript</c:v>
+                </c:pt>
+                <c:pt idx="5">
+                  <c:v>HTML/CSS</c:v>
+                </c:pt>
+                <c:pt idx="6">
                   <c:v>SQL</c:v>
                 </c:pt>
-                <c:pt idx="5">
+                <c:pt idx="7">
                   <c:v>Python</c:v>
-                </c:pt>
-                <c:pt idx="6">
-                  <c:v>HTML/CSS</c:v>
-                </c:pt>
-                <c:pt idx="7">
-                  <c:v>JavaScript</c:v>
                 </c:pt>
               </c:strCache>
             </c:strRef>
@@ -203,28 +203,28 @@
                 <c:formatCode>General</c:formatCode>
                 <c:ptCount val="8"/>
                 <c:pt idx="0">
-                  <c:v>2987</c:v>
+                  <c:v>7414</c:v>
                 </c:pt>
                 <c:pt idx="1">
-                  <c:v>3135</c:v>
+                  <c:v>8662</c:v>
                 </c:pt>
                 <c:pt idx="2">
-                  <c:v>3639</c:v>
+                  <c:v>9262</c:v>
                 </c:pt>
                 <c:pt idx="3">
-                  <c:v>4140</c:v>
+                  <c:v>10099</c:v>
                 </c:pt>
                 <c:pt idx="4">
-                  <c:v>5094</c:v>
+                  <c:v>10581</c:v>
                 </c:pt>
                 <c:pt idx="5">
-                  <c:v>5309</c:v>
+                  <c:v>10661</c:v>
                 </c:pt>
                 <c:pt idx="6">
-                  <c:v>5398</c:v>
+                  <c:v>11257</c:v>
                 </c:pt>
                 <c:pt idx="7">
-                  <c:v>6715</c:v>
+                  <c:v>12419</c:v>
                 </c:pt>
               </c:numCache>
             </c:numRef>
@@ -339,7 +339,7 @@
                   <c:v>Microsoft SQL Server</c:v>
                 </c:pt>
                 <c:pt idx="1">
-                  <c:v>Elasticsearch</c:v>
+                  <c:v>MongoDB</c:v>
                 </c:pt>
                 <c:pt idx="2">
                   <c:v>MySQL</c:v>
@@ -348,7 +348,7 @@
                   <c:v>Redis</c:v>
                 </c:pt>
                 <c:pt idx="4">
-                  <c:v>MongoDB</c:v>
+                  <c:v>SQLite</c:v>
                 </c:pt>
                 <c:pt idx="5">
                   <c:v>PostgreSQL</c:v>
@@ -363,22 +363,22 @@
                 <c:formatCode>General</c:formatCode>
                 <c:ptCount val="6"/>
                 <c:pt idx="0">
-                  <c:v>4170</c:v>
+                  <c:v>7871</c:v>
                 </c:pt>
                 <c:pt idx="1">
-                  <c:v>1980</c:v>
+                  <c:v>6267</c:v>
                 </c:pt>
                 <c:pt idx="2">
-                  <c:v>5549</c:v>
+                  <c:v>10581</c:v>
                 </c:pt>
                 <c:pt idx="3">
-                  <c:v>2536</c:v>
+                  <c:v>7316</c:v>
                 </c:pt>
                 <c:pt idx="4">
-                  <c:v>3058</c:v>
+                  <c:v>9798</c:v>
                 </c:pt>
                 <c:pt idx="5">
-                  <c:v>4153</c:v>
+                  <c:v>14529</c:v>
                 </c:pt>
               </c:numCache>
             </c:numRef>
@@ -412,7 +412,7 @@
                   <c:v>Microsoft SQL Server</c:v>
                 </c:pt>
                 <c:pt idx="1">
-                  <c:v>Elasticsearch</c:v>
+                  <c:v>MongoDB</c:v>
                 </c:pt>
                 <c:pt idx="2">
                   <c:v>MySQL</c:v>
@@ -421,7 +421,7 @@
                   <c:v>Redis</c:v>
                 </c:pt>
                 <c:pt idx="4">
-                  <c:v>MongoDB</c:v>
+                  <c:v>SQLite</c:v>
                 </c:pt>
                 <c:pt idx="5">
                   <c:v>PostgreSQL</c:v>
@@ -436,22 +436,22 @@
                 <c:formatCode>General</c:formatCode>
                 <c:ptCount val="6"/>
                 <c:pt idx="0">
-                  <c:v>2747</c:v>
+                  <c:v>3851</c:v>
                 </c:pt>
                 <c:pt idx="1">
-                  <c:v>2898</c:v>
+                  <c:v>4421</c:v>
                 </c:pt>
                 <c:pt idx="2">
-                  <c:v>3328</c:v>
+                  <c:v>5120</c:v>
                 </c:pt>
                 <c:pt idx="3">
-                  <c:v>3385</c:v>
+                  <c:v>6014</c:v>
                 </c:pt>
                 <c:pt idx="4">
-                  <c:v>3703</c:v>
+                  <c:v>7185</c:v>
                 </c:pt>
                 <c:pt idx="5">
-                  <c:v>4386</c:v>
+                  <c:v>11863</c:v>
                 </c:pt>
               </c:numCache>
             </c:numRef>
@@ -714,7 +714,7 @@
             <c:idx val="0"/>
             <c:spPr>
               <a:solidFill>
-                <a:srgbClr val="16A34A"/>
+                <a:srgbClr val="DC2626"/>
               </a:solidFill>
             </c:spPr>
           </c:dPt>
@@ -722,7 +722,7 @@
             <c:idx val="1"/>
             <c:spPr>
               <a:solidFill>
-                <a:srgbClr val="16A34A"/>
+                <a:srgbClr val="DC2626"/>
               </a:solidFill>
             </c:spPr>
           </c:dPt>
@@ -730,7 +730,7 @@
             <c:idx val="2"/>
             <c:spPr>
               <a:solidFill>
-                <a:srgbClr val="16A34A"/>
+                <a:srgbClr val="DC2626"/>
               </a:solidFill>
             </c:spPr>
           </c:dPt>
@@ -746,7 +746,7 @@
             <c:idx val="4"/>
             <c:spPr>
               <a:solidFill>
-                <a:srgbClr val="DC2626"/>
+                <a:srgbClr val="16A34A"/>
               </a:solidFill>
             </c:spPr>
           </c:dPt>
@@ -762,7 +762,7 @@
             <c:idx val="6"/>
             <c:spPr>
               <a:solidFill>
-                <a:srgbClr val="16A34A"/>
+                <a:srgbClr val="DC2626"/>
               </a:solidFill>
             </c:spPr>
           </c:dPt>
@@ -796,34 +796,34 @@
               <c:strCache>
                 <c:ptCount val="10"/>
                 <c:pt idx="0">
-                  <c:v>Kotlin</c:v>
+                  <c:v>PHP</c:v>
                 </c:pt>
                 <c:pt idx="1">
+                  <c:v>TypeScript</c:v>
+                </c:pt>
+                <c:pt idx="2">
+                  <c:v>PowerShell</c:v>
+                </c:pt>
+                <c:pt idx="3">
+                  <c:v>Java</c:v>
+                </c:pt>
+                <c:pt idx="4">
                   <c:v>Rust</c:v>
                 </c:pt>
-                <c:pt idx="2">
-                  <c:v>WebAssembly</c:v>
-                </c:pt>
-                <c:pt idx="3">
-                  <c:v>PHP</c:v>
-                </c:pt>
-                <c:pt idx="4">
-                  <c:v>Bash/Shell/PowerShell</c:v>
-                </c:pt>
                 <c:pt idx="5">
-                  <c:v>Java</c:v>
+                  <c:v>Python</c:v>
                 </c:pt>
                 <c:pt idx="6">
-                  <c:v>Go</c:v>
+                  <c:v>Bash/Shell (all shells)</c:v>
                 </c:pt>
                 <c:pt idx="7">
+                  <c:v>SQL</c:v>
+                </c:pt>
+                <c:pt idx="8">
+                  <c:v>HTML/CSS</c:v>
+                </c:pt>
+                <c:pt idx="9">
                   <c:v>JavaScript</c:v>
-                </c:pt>
-                <c:pt idx="8">
-                  <c:v>SQL</c:v>
-                </c:pt>
-                <c:pt idx="9">
-                  <c:v>HTML/CSS</c:v>
                 </c:pt>
               </c:strCache>
             </c:strRef>
@@ -835,34 +835,34 @@
                 <c:formatCode>General</c:formatCode>
                 <c:ptCount val="10"/>
                 <c:pt idx="0">
-                  <c:v>1153</c:v>
+                  <c:v>-3121</c:v>
                 </c:pt>
                 <c:pt idx="1">
-                  <c:v>1212</c:v>
+                  <c:v>-3760</c:v>
                 </c:pt>
                 <c:pt idx="2">
-                  <c:v>1281</c:v>
+                  <c:v>-4357</c:v>
                 </c:pt>
                 <c:pt idx="3">
-                  <c:v>-1475</c:v>
+                  <c:v>-4377</c:v>
                 </c:pt>
                 <c:pt idx="4">
-                  <c:v>-1559</c:v>
+                  <c:v>4538</c:v>
                 </c:pt>
                 <c:pt idx="5">
-                  <c:v>-1569</c:v>
+                  <c:v>-5991</c:v>
                 </c:pt>
                 <c:pt idx="6">
-                  <c:v>1680</c:v>
+                  <c:v>-6841</c:v>
                 </c:pt>
                 <c:pt idx="7">
-                  <c:v>-2090</c:v>
+                  <c:v>-7376</c:v>
                 </c:pt>
                 <c:pt idx="8">
-                  <c:v>-2119</c:v>
+                  <c:v>-9037</c:v>
                 </c:pt>
                 <c:pt idx="9">
-                  <c:v>-2522</c:v>
+                  <c:v>-10424</c:v>
                 </c:pt>
               </c:numCache>
             </c:numRef>
@@ -974,34 +974,34 @@
               <c:strCache>
                 <c:ptCount val="10"/>
                 <c:pt idx="0">
-                  <c:v>R</c:v>
+                  <c:v>Bash/Shell (all shells)</c:v>
                 </c:pt>
                 <c:pt idx="1">
-                  <c:v>Python</c:v>
+                  <c:v>Go</c:v>
                 </c:pt>
                 <c:pt idx="2">
-                  <c:v>Objective-C</c:v>
+                  <c:v>Lisp</c:v>
                 </c:pt>
                 <c:pt idx="3">
-                  <c:v>Bash/Shell/PowerShell</c:v>
+                  <c:v>Groovy</c:v>
                 </c:pt>
                 <c:pt idx="4">
-                  <c:v>Rust</c:v>
+                  <c:v>Swift</c:v>
                 </c:pt>
                 <c:pt idx="5">
+                  <c:v>Scala</c:v>
+                </c:pt>
+                <c:pt idx="6">
                   <c:v>Elixir</c:v>
                 </c:pt>
-                <c:pt idx="6">
+                <c:pt idx="7">
+                  <c:v>Perl</c:v>
+                </c:pt>
+                <c:pt idx="8">
+                  <c:v>Erlang</c:v>
+                </c:pt>
+                <c:pt idx="9">
                   <c:v>Ruby</c:v>
-                </c:pt>
-                <c:pt idx="7">
-                  <c:v>Scala</c:v>
-                </c:pt>
-                <c:pt idx="8">
-                  <c:v>Go</c:v>
-                </c:pt>
-                <c:pt idx="9">
-                  <c:v>Clojure</c:v>
                 </c:pt>
               </c:strCache>
             </c:strRef>
@@ -1013,34 +1013,34 @@
                 <c:formatCode>General</c:formatCode>
                 <c:ptCount val="10"/>
                 <c:pt idx="0">
-                  <c:v>63016</c:v>
+                  <c:v>83531</c:v>
                 </c:pt>
                 <c:pt idx="1">
-                  <c:v>64000</c:v>
+                  <c:v>89815</c:v>
                 </c:pt>
                 <c:pt idx="2">
-                  <c:v>64115</c:v>
+                  <c:v>90000</c:v>
                 </c:pt>
                 <c:pt idx="3">
-                  <c:v>68745</c:v>
+                  <c:v>90233</c:v>
                 </c:pt>
                 <c:pt idx="4">
-                  <c:v>70000</c:v>
+                  <c:v>92000</c:v>
                 </c:pt>
                 <c:pt idx="5">
-                  <c:v>71966</c:v>
+                  <c:v>96524</c:v>
                 </c:pt>
                 <c:pt idx="6">
-                  <c:v>75000</c:v>
+                  <c:v>99194</c:v>
                 </c:pt>
                 <c:pt idx="7">
-                  <c:v>79163</c:v>
+                  <c:v>99886</c:v>
                 </c:pt>
                 <c:pt idx="8">
-                  <c:v>80000</c:v>
+                  <c:v>100000</c:v>
                 </c:pt>
                 <c:pt idx="9">
-                  <c:v>93404</c:v>
+                  <c:v>102961</c:v>
                 </c:pt>
               </c:numCache>
             </c:numRef>
@@ -1152,25 +1152,25 @@
               <c:strCache>
                 <c:ptCount val="7"/>
                 <c:pt idx="0">
-                  <c:v>Bash/Shell/PowerShell</c:v>
+                  <c:v>Bash/Shell (all shells)</c:v>
                 </c:pt>
                 <c:pt idx="1">
-                  <c:v>C#</c:v>
+                  <c:v>Rust</c:v>
                 </c:pt>
                 <c:pt idx="2">
                   <c:v>TypeScript</c:v>
                 </c:pt>
                 <c:pt idx="3">
+                  <c:v>JavaScript</c:v>
+                </c:pt>
+                <c:pt idx="4">
+                  <c:v>HTML/CSS</c:v>
+                </c:pt>
+                <c:pt idx="5">
                   <c:v>SQL</c:v>
                 </c:pt>
-                <c:pt idx="4">
+                <c:pt idx="6">
                   <c:v>Python</c:v>
-                </c:pt>
-                <c:pt idx="5">
-                  <c:v>HTML/CSS</c:v>
-                </c:pt>
-                <c:pt idx="6">
-                  <c:v>JavaScript</c:v>
                 </c:pt>
               </c:strCache>
             </c:strRef>
@@ -1182,25 +1182,25 @@
                 <c:formatCode>General</c:formatCode>
                 <c:ptCount val="7"/>
                 <c:pt idx="0">
-                  <c:v>3135</c:v>
+                  <c:v>8662</c:v>
                 </c:pt>
                 <c:pt idx="1">
-                  <c:v>3639</c:v>
+                  <c:v>9262</c:v>
                 </c:pt>
                 <c:pt idx="2">
-                  <c:v>4140</c:v>
+                  <c:v>10099</c:v>
                 </c:pt>
                 <c:pt idx="3">
-                  <c:v>5094</c:v>
+                  <c:v>10581</c:v>
                 </c:pt>
                 <c:pt idx="4">
-                  <c:v>5309</c:v>
+                  <c:v>10661</c:v>
                 </c:pt>
                 <c:pt idx="5">
-                  <c:v>5398</c:v>
+                  <c:v>11257</c:v>
                 </c:pt>
                 <c:pt idx="6">
-                  <c:v>6715</c:v>
+                  <c:v>12419</c:v>
                 </c:pt>
               </c:numCache>
             </c:numRef>
@@ -1315,7 +1315,7 @@
                   <c:v>Microsoft SQL Server</c:v>
                 </c:pt>
                 <c:pt idx="1">
-                  <c:v>Elasticsearch</c:v>
+                  <c:v>MongoDB</c:v>
                 </c:pt>
                 <c:pt idx="2">
                   <c:v>MySQL</c:v>
@@ -1324,7 +1324,7 @@
                   <c:v>Redis</c:v>
                 </c:pt>
                 <c:pt idx="4">
-                  <c:v>MongoDB</c:v>
+                  <c:v>SQLite</c:v>
                 </c:pt>
                 <c:pt idx="5">
                   <c:v>PostgreSQL</c:v>
@@ -1339,22 +1339,22 @@
                 <c:formatCode>General</c:formatCode>
                 <c:ptCount val="6"/>
                 <c:pt idx="0">
-                  <c:v>2747</c:v>
+                  <c:v>3851</c:v>
                 </c:pt>
                 <c:pt idx="1">
-                  <c:v>2898</c:v>
+                  <c:v>4421</c:v>
                 </c:pt>
                 <c:pt idx="2">
-                  <c:v>3328</c:v>
+                  <c:v>5120</c:v>
                 </c:pt>
                 <c:pt idx="3">
-                  <c:v>3385</c:v>
+                  <c:v>6014</c:v>
                 </c:pt>
                 <c:pt idx="4">
-                  <c:v>3703</c:v>
+                  <c:v>7185</c:v>
                 </c:pt>
                 <c:pt idx="5">
-                  <c:v>4386</c:v>
+                  <c:v>11863</c:v>
                 </c:pt>
               </c:numCache>
             </c:numRef>
@@ -1491,7 +1491,7 @@
             <c:idx val="4"/>
             <c:spPr>
               <a:solidFill>
-                <a:srgbClr val="F59E0B"/>
+                <a:srgbClr val="64748B"/>
               </a:solidFill>
             </c:spPr>
           </c:dPt>
@@ -1499,7 +1499,7 @@
             <c:idx val="5"/>
             <c:spPr>
               <a:solidFill>
-                <a:srgbClr val="F59E0B"/>
+                <a:srgbClr val="64748B"/>
               </a:solidFill>
             </c:spPr>
           </c:dPt>
@@ -1525,22 +1525,22 @@
               <c:strCache>
                 <c:ptCount val="8"/>
                 <c:pt idx="0">
+                  <c:v>Data/BI Analyst</c:v>
+                </c:pt>
+                <c:pt idx="1">
+                  <c:v>Front-end Developer</c:v>
+                </c:pt>
+                <c:pt idx="2">
                   <c:v>Mobile Developer</c:v>
                 </c:pt>
-                <c:pt idx="1">
+                <c:pt idx="3">
                   <c:v>Data Scientist / ML</c:v>
                 </c:pt>
-                <c:pt idx="2">
-                  <c:v>Data/BI Analyst</c:v>
-                </c:pt>
-                <c:pt idx="3">
+                <c:pt idx="4">
+                  <c:v>DevOps Specialist</c:v>
+                </c:pt>
+                <c:pt idx="5">
                   <c:v>Product/BA</c:v>
-                </c:pt>
-                <c:pt idx="4">
-                  <c:v>Front-end Developer</c:v>
-                </c:pt>
-                <c:pt idx="5">
-                  <c:v>DevOps Specialist</c:v>
                 </c:pt>
                 <c:pt idx="6">
                   <c:v>Back-end Developer</c:v>
@@ -1558,28 +1558,28 @@
                 <c:formatCode>General</c:formatCode>
                 <c:ptCount val="8"/>
                 <c:pt idx="0">
-                  <c:v>23.5</c:v>
+                  <c:v>0.0</c:v>
                 </c:pt>
                 <c:pt idx="1">
-                  <c:v>28.9</c:v>
+                  <c:v>12.3</c:v>
                 </c:pt>
                 <c:pt idx="2">
-                  <c:v>30.8</c:v>
+                  <c:v>12.6</c:v>
                 </c:pt>
                 <c:pt idx="3">
-                  <c:v>33.3</c:v>
+                  <c:v>13.0</c:v>
                 </c:pt>
                 <c:pt idx="4">
-                  <c:v>45.2</c:v>
+                  <c:v>18.4</c:v>
                 </c:pt>
                 <c:pt idx="5">
+                  <c:v>35.4</c:v>
+                </c:pt>
+                <c:pt idx="6">
                   <c:v>46.1</c:v>
                 </c:pt>
-                <c:pt idx="6">
-                  <c:v>65.9</c:v>
-                </c:pt>
                 <c:pt idx="7">
-                  <c:v>72.9</c:v>
+                  <c:v>77.2</c:v>
                 </c:pt>
               </c:numCache>
             </c:numRef>

</xml_diff>